<commit_message>
Replay complete trajectories at 3x and preserve updated NIPS cover
</commit_message>
<xml_diff>
--- a/DPIAgent/assets/demo/dpiagent-cover.pptx
+++ b/DPIAgent/assets/demo/dpiagent-cover.pptx
@@ -5,10 +5,10 @@
     <p:sldMasterId id="2147483648" r:id="rId2"/>
   </p:sldMasterIdLst>
   <p:notesMasterIdLst>
-    <p:notesMasterId r:id="rId16"/>
+    <p:notesMasterId r:id="rId7"/>
   </p:notesMasterIdLst>
   <p:handoutMasterIdLst>
-    <p:handoutMasterId r:id="rId17"/>
+    <p:handoutMasterId r:id="rId8"/>
   </p:handoutMasterIdLst>
   <p:sldIdLst>
     <p:sldId id="260" r:id="rId3"/>
@@ -16,7 +16,7 @@
   <p:sldSz cx="12192000" cy="6858000"/>
   <p:notesSz cx="10234613" cy="7104063"/>
   <p:custDataLst>
-    <p:tags r:id="rId18"/>
+    <p:tags r:id="rId9"/>
   </p:custDataLst>
   <p:defaultTextStyle>
     <a:defPPr>
@@ -227,7 +227,7 @@
           <a:p>
             <a:fld id="{0F9B84EA-7D68-4D60-9CB1-D50884785D1C}" type="datetimeFigureOut">
               <a:rPr lang="zh-CN" altLang="en-US" smtClean="0"/>
-              <a:t>2026/5/30</a:t>
+              <a:t>2026/10/27</a:t>
             </a:fld>
             <a:endParaRPr lang="zh-CN" altLang="en-US"/>
           </a:p>
@@ -392,7 +392,7 @@
           <a:p>
             <a:fld id="{D6C8D182-E4C8-4120-9249-FC9774456FFA}" type="datetimeFigureOut">
               <a:rPr lang="zh-CN" altLang="en-US" smtClean="0"/>
-              <a:t>2026/5/30</a:t>
+              <a:t>2026/10/27</a:t>
             </a:fld>
             <a:endParaRPr lang="zh-CN" altLang="en-US"/>
           </a:p>
@@ -812,7 +812,7 @@
           <a:p>
             <a:fld id="{760FBDFE-C587-4B4C-A407-44438C67B59E}" type="datetimeFigureOut">
               <a:rPr lang="zh-CN" altLang="en-US" smtClean="0"/>
-              <a:t>2026/5/30</a:t>
+              <a:t>2026/10/27</a:t>
             </a:fld>
             <a:endParaRPr lang="zh-CN" altLang="en-US"/>
           </a:p>
@@ -978,7 +978,7 @@
           <a:p>
             <a:fld id="{760FBDFE-C587-4B4C-A407-44438C67B59E}" type="datetimeFigureOut">
               <a:rPr lang="zh-CN" altLang="en-US" smtClean="0"/>
-              <a:t>2026/5/30</a:t>
+              <a:t>2026/10/27</a:t>
             </a:fld>
             <a:endParaRPr lang="zh-CN" altLang="en-US"/>
           </a:p>
@@ -1268,7 +1268,7 @@
           <a:p>
             <a:fld id="{760FBDFE-C587-4B4C-A407-44438C67B59E}" type="datetimeFigureOut">
               <a:rPr lang="zh-CN" altLang="en-US" smtClean="0"/>
-              <a:t>2026/5/30</a:t>
+              <a:t>2026/10/27</a:t>
             </a:fld>
             <a:endParaRPr lang="zh-CN" altLang="en-US"/>
           </a:p>
@@ -1512,7 +1512,7 @@
           <a:p>
             <a:fld id="{760FBDFE-C587-4B4C-A407-44438C67B59E}" type="datetimeFigureOut">
               <a:rPr lang="zh-CN" altLang="en-US" smtClean="0"/>
-              <a:t>2026/5/30</a:t>
+              <a:t>2026/10/27</a:t>
             </a:fld>
             <a:endParaRPr lang="zh-CN" altLang="en-US"/>
           </a:p>
@@ -1885,7 +1885,7 @@
           <a:p>
             <a:fld id="{760FBDFE-C587-4B4C-A407-44438C67B59E}" type="datetimeFigureOut">
               <a:rPr lang="zh-CN" altLang="en-US" smtClean="0"/>
-              <a:t>2026/5/30</a:t>
+              <a:t>2026/10/27</a:t>
             </a:fld>
             <a:endParaRPr lang="zh-CN" altLang="en-US"/>
           </a:p>
@@ -2248,7 +2248,7 @@
           <a:p>
             <a:fld id="{760FBDFE-C587-4B4C-A407-44438C67B59E}" type="datetimeFigureOut">
               <a:rPr lang="zh-CN" altLang="en-US" smtClean="0"/>
-              <a:t>2026/5/30</a:t>
+              <a:t>2026/10/27</a:t>
             </a:fld>
             <a:endParaRPr lang="zh-CN" altLang="en-US"/>
           </a:p>
@@ -2373,7 +2373,7 @@
           <a:p>
             <a:fld id="{760FBDFE-C587-4B4C-A407-44438C67B59E}" type="datetimeFigureOut">
               <a:rPr lang="zh-CN" altLang="en-US" smtClean="0"/>
-              <a:t>2026/5/30</a:t>
+              <a:t>2026/10/27</a:t>
             </a:fld>
             <a:endParaRPr lang="zh-CN" altLang="en-US"/>
           </a:p>
@@ -2463,7 +2463,7 @@
           <a:p>
             <a:fld id="{760FBDFE-C587-4B4C-A407-44438C67B59E}" type="datetimeFigureOut">
               <a:rPr lang="zh-CN" altLang="en-US" smtClean="0"/>
-              <a:t>2026/5/30</a:t>
+              <a:t>2026/10/27</a:t>
             </a:fld>
             <a:endParaRPr lang="zh-CN" altLang="en-US"/>
           </a:p>
@@ -2719,7 +2719,7 @@
           <a:p>
             <a:fld id="{9EFD9D74-47D9-4702-A33C-335B63B48DBF}" type="datetimeFigureOut">
               <a:rPr lang="zh-CN" altLang="en-US" smtClean="0"/>
-              <a:t>2026/5/30</a:t>
+              <a:t>2026/10/27</a:t>
             </a:fld>
             <a:endParaRPr lang="zh-CN" altLang="en-US" dirty="0"/>
           </a:p>
@@ -2898,7 +2898,7 @@
           <a:p>
             <a:fld id="{760FBDFE-C587-4B4C-A407-44438C67B59E}" type="datetimeFigureOut">
               <a:rPr lang="zh-CN" altLang="en-US" smtClean="0"/>
-              <a:t>2026/5/30</a:t>
+              <a:t>2026/10/27</a:t>
             </a:fld>
             <a:endParaRPr lang="zh-CN" altLang="en-US"/>
           </a:p>
@@ -3109,7 +3109,7 @@
           <a:p>
             <a:fld id="{760FBDFE-C587-4B4C-A407-44438C67B59E}" type="datetimeFigureOut">
               <a:rPr lang="zh-CN" altLang="en-US" smtClean="0"/>
-              <a:t>2026/5/30</a:t>
+              <a:t>2026/10/27</a:t>
             </a:fld>
             <a:endParaRPr lang="zh-CN" altLang="en-US" dirty="0"/>
           </a:p>
@@ -3501,7 +3501,7 @@
     <p:bg>
       <p:bgPr>
         <a:blipFill>
-          <a:blip r:embed="rId6"/>
+          <a:blip r:embed="rId5"/>
           <a:stretch>
             <a:fillRect/>
           </a:stretch>
@@ -3586,7 +3586,7 @@
           <p:nvPr>
             <p:ph type="subTitle" idx="1"/>
             <p:custDataLst>
-              <p:tags r:id="rId2"/>
+              <p:tags r:id="rId1"/>
             </p:custDataLst>
           </p:nvPr>
         </p:nvSpPr>
@@ -3830,7 +3830,7 @@
           <p:nvPr>
             <p:ph type="ctrTitle"/>
             <p:custDataLst>
-              <p:tags r:id="rId3"/>
+              <p:tags r:id="rId2"/>
             </p:custDataLst>
           </p:nvPr>
         </p:nvSpPr>
@@ -3951,7 +3951,7 @@
           <p:nvPr/>
         </p:nvPicPr>
         <p:blipFill>
-          <a:blip r:embed="rId9"/>
+          <a:blip r:embed="rId6"/>
           <a:stretch>
             <a:fillRect/>
           </a:stretch>
@@ -3981,14 +3981,14 @@
           <p:nvPr/>
         </p:nvPicPr>
         <p:blipFill>
-          <a:blip r:embed="rId12"/>
+          <a:blip r:embed="rId7"/>
           <a:stretch>
             <a:fillRect/>
           </a:stretch>
         </p:blipFill>
         <p:spPr>
           <a:xfrm>
-            <a:off x="7498079" y="5705856"/>
+            <a:off x="7381945" y="5760720"/>
             <a:ext cx="310896" cy="310896"/>
           </a:xfrm>
           <a:prstGeom prst="rect">
@@ -3996,44 +3996,44 @@
           </a:prstGeom>
         </p:spPr>
       </p:pic>
-      <p:sp>
-        <p:nvSpPr>
-          <p:cNvPr id="15" name="TextBox 14"/>
-          <p:cNvSpPr txBox="1"/>
+      <p:pic>
+        <p:nvPicPr>
+          <p:cNvPr id="3" name="图片 2" descr="Press">
+            <a:extLst>
+              <a:ext uri="{FF2B5EF4-FFF2-40B4-BE49-F238E27FC236}">
+                <a16:creationId xmlns:a16="http://schemas.microsoft.com/office/drawing/2014/main" id="{5A05AC99-6C40-AEB8-A641-21B85E1D85E3}"/>
+              </a:ext>
+            </a:extLst>
+          </p:cNvPr>
+          <p:cNvPicPr>
+            <a:picLocks noChangeAspect="1"/>
+          </p:cNvPicPr>
           <p:nvPr/>
-        </p:nvSpPr>
+        </p:nvPicPr>
+        <p:blipFill>
+          <a:blip r:embed="rId8"/>
+          <a:stretch>
+            <a:fillRect/>
+          </a:stretch>
+        </p:blipFill>
         <p:spPr>
           <a:xfrm>
-            <a:off x="8686800" y="320040"/>
-            <a:ext cx="2651760" cy="548640"/>
+            <a:off x="735149" y="137287"/>
+            <a:ext cx="1801223" cy="818738"/>
           </a:xfrm>
           <a:prstGeom prst="rect">
             <a:avLst/>
           </a:prstGeom>
-          <a:noFill/>
         </p:spPr>
-        <p:txBody>
-          <a:bodyPr wrap="none">
-            <a:spAutoFit/>
-          </a:bodyPr>
-          <a:lstStyle/>
-          <a:p>
-            <a:pPr algn="r">
-              <a:defRPr sz="3000" b="1">
-                <a:latin typeface="Arial"/>
-              </a:defRPr>
-            </a:pPr>
-            <a:r>
-              <a:t>NeurIPS 2026</a:t>
-            </a:r>
-          </a:p>
-        </p:txBody>
-      </p:sp>
+      </p:pic>
     </p:spTree>
   </p:cSld>
   <p:clrMapOvr>
     <a:masterClrMapping/>
   </p:clrMapOvr>
+  <p:transition spd="slow" advTm="4000">
+    <p:fade/>
+  </p:transition>
 </p:sld>
 </file>
 
@@ -4050,12 +4050,6 @@
 </file>
 
 <file path=ppt/tags/tag3.xml><?xml version="1.0" encoding="utf-8"?>
-<p:tagLst xmlns:a="http://schemas.openxmlformats.org/drawingml/2006/main" xmlns:r="http://schemas.openxmlformats.org/officeDocument/2006/relationships" xmlns:p="http://schemas.openxmlformats.org/presentationml/2006/main">
-  <p:tag name="KSO_WM_BEAUTIFY_FLAG" val=""/>
-</p:tagLst>
-</file>
-
-<file path=ppt/tags/tag4.xml><?xml version="1.0" encoding="utf-8"?>
 <p:tagLst xmlns:a="http://schemas.openxmlformats.org/drawingml/2006/main" xmlns:r="http://schemas.openxmlformats.org/officeDocument/2006/relationships" xmlns:p="http://schemas.openxmlformats.org/presentationml/2006/main">
   <p:tag name="KSO_WM_BEAUTIFY_FLAG" val=""/>
 </p:tagLst>

</xml_diff>